<commit_message>
Rename group member Mahmoud El-Serwy to Mahmoud Ibrahim across all deliverables
- web: lecture-2 portal + presentation, lecture-1 hub + NBE deck
- downloads: rebuilt Ch5 deck, NBE deck, banking report (+ PDFs) with corrected name

Co-Authored-By: Claude Opus 4.8 (1M context) <noreply@anthropic.com>
</commit_message>
<xml_diff>
--- a/downloads/Lecture2_Ch5_Data_Resource_Management.pptx
+++ b/downloads/Lecture2_Ch5_Data_Resource_Management.pptx
@@ -2911,7 +2911,7 @@
                   <a:srgbClr val="FFFFFF"/>
                 </a:solidFill>
               </a:rPr>
-              <a:t>Ahmed Awad   |   Tariq Salama   |   Ahmed Sabri   |   Mahmoud El-Serwy</a:t>
+              <a:t>Ahmed Awad   |   Tariq Salama   |   Ahmed Sabri   |   Mahmoud Ibrahim</a:t>
             </a:r>
             <a:endParaRPr lang="en-US" sz="1300" dirty="0"/>
           </a:p>
@@ -15302,7 +15302,7 @@
                   <a:srgbClr val="B9CBDD"/>
                 </a:solidFill>
               </a:rPr>
-              <a:t>Ahmed Awad   |   Tariq Salama   |   Ahmed Sabri   |   Mahmoud El-Serwy</a:t>
+              <a:t>Ahmed Awad   |   Tariq Salama   |   Ahmed Sabri   |   Mahmoud Ibrahim</a:t>
             </a:r>
             <a:endParaRPr lang="en-US" sz="1300" dirty="0"/>
           </a:p>

</xml_diff>